<commit_message>
Add a discussion slide to every domain and management seminar
Each deck ends with an identical Discussion slide: one practical
question plus a fixed prompt to draw on students' own experience
and career. Technical seminars are unchanged; the lab serves that role.

Co-Authored-By: Claude Opus 5.5 <noreply@anthropic.com>
Claude-Session: https://claude.ai/code/session_01XYJ4xmrADRJAP7ufCAYieX
</commit_message>
<xml_diff>
--- a/domain-seminars/week01_domain_overview.pptx
+++ b/domain-seminars/week01_domain_overview.pptx
@@ -11,6 +11,7 @@
     <p:sldId id="269" r:id="rId20"/>
     <p:sldId id="270" r:id="rId21"/>
     <p:sldId id="271" r:id="rId22"/>
+    <p:sldId id="272" r:id="rId11"/>
   </p:sldIdLst>
   <p:notesMasterIdLst>
     <p:notesMasterId r:id="rId12"/>
@@ -857,6 +858,76 @@
           <a:p>
             <a:r>
               <a:t>Most bad numbers come from misunderstanding the data, not from bad math. A join at the wrong grain (claim lines to claim headers, or claims to member-months) silently double-counts dollars. Primary keys identify a row; foreign keys connect tables. Following one person through coverage, visits and prescriptions is the fastest way to learn how the tables fit together.</a:t>
+            </a:r>
+          </a:p>
+        </p:txBody>
+      </p:sp>
+      <p:sp>
+        <p:nvSpPr>
+          <p:cNvPr id="4" name="Slide Number Placeholder 3"/>
+          <p:cNvSpPr>
+            <a:spLocks noGrp="1"/>
+          </p:cNvSpPr>
+          <p:nvPr>
+            <p:ph type="sldNum" idx="5" sz="quarter"/>
+          </p:nvPr>
+        </p:nvSpPr>
+        <p:spPr/>
+      </p:sp>
+    </p:spTree>
+  </p:cSld>
+  <p:clrMapOvr>
+    <a:masterClrMapping/>
+  </p:clrMapOvr>
+</p:notes>
+</file>
+
+<file path=ppt/notesSlides/notesSlide7.xml><?xml version="1.0" encoding="utf-8"?>
+<p:notes xmlns:a="http://schemas.openxmlformats.org/drawingml/2006/main" xmlns:p="http://schemas.openxmlformats.org/presentationml/2006/main" xmlns:r="http://schemas.openxmlformats.org/officeDocument/2006/relationships">
+  <p:cSld>
+    <p:spTree>
+      <p:nvGrpSpPr>
+        <p:cNvPr id="1" name=""/>
+        <p:cNvGrpSpPr/>
+        <p:nvPr/>
+      </p:nvGrpSpPr>
+      <p:grpSpPr>
+        <a:xfrm>
+          <a:off x="0" y="0"/>
+          <a:ext cx="0" cy="0"/>
+          <a:chOff x="0" y="0"/>
+          <a:chExt cx="0" cy="0"/>
+        </a:xfrm>
+      </p:grpSpPr>
+      <p:sp>
+        <p:nvSpPr>
+          <p:cNvPr id="2" name="Slide Image Placeholder 1"/>
+          <p:cNvSpPr>
+            <a:spLocks noGrp="1"/>
+          </p:cNvSpPr>
+          <p:nvPr>
+            <p:ph type="sldImg" idx="2"/>
+          </p:nvPr>
+        </p:nvSpPr>
+        <p:spPr/>
+      </p:sp>
+      <p:sp>
+        <p:nvSpPr>
+          <p:cNvPr id="3" name="Notes Placeholder 2"/>
+          <p:cNvSpPr>
+            <a:spLocks noGrp="1"/>
+          </p:cNvSpPr>
+          <p:nvPr>
+            <p:ph type="body" idx="3" sz="quarter"/>
+          </p:nvPr>
+        </p:nvSpPr>
+        <p:spPr/>
+        <p:txBody>
+          <a:bodyPr/>
+          <a:lstStyle/>
+          <a:p>
+            <a:r>
+              <a:t>Give students a few minutes to write an answer drawn from their own experience and career, then ask two or three to share. Connect their examples back to this seminar's content. In an online section, post the same question to the discussion board.</a:t>
             </a:r>
           </a:p>
         </p:txBody>
@@ -2572,6 +2643,167 @@
             <a:fld id="{F7021451-1387-4CA6-816F-3879F97B5CBC}" type="slidenum">
               <a:rPr b="0" lang="en-US"/>
               <a:t>6</a:t>
+            </a:fld>
+            <a:endParaRPr lang="en-US"/>
+          </a:p>
+        </p:txBody>
+      </p:sp>
+    </p:spTree>
+  </p:cSld>
+  <p:clrMapOvr>
+    <a:masterClrMapping/>
+  </p:clrMapOvr>
+</p:sld>
+</file>
+
+<file path=ppt/slides/slide7.xml><?xml version="1.0" encoding="utf-8"?>
+<p:sld xmlns:a="http://schemas.openxmlformats.org/drawingml/2006/main" xmlns:p="http://schemas.openxmlformats.org/presentationml/2006/main" xmlns:r="http://schemas.openxmlformats.org/officeDocument/2006/relationships">
+  <p:cSld>
+    <p:spTree>
+      <p:nvGrpSpPr>
+        <p:cNvPr id="1" name=""/>
+        <p:cNvGrpSpPr/>
+        <p:nvPr/>
+      </p:nvGrpSpPr>
+      <p:grpSpPr/>
+      <p:sp>
+        <p:nvSpPr>
+          <p:cNvPr id="2" name="Text 0"/>
+          <p:cNvSpPr/>
+          <p:nvPr>
+            <p:ph idx="100" type="title" hasCustomPrompt="1"/>
+          </p:nvPr>
+        </p:nvSpPr>
+        <p:spPr>
+          <a:xfrm>
+            <a:off x="731520" y="457200"/>
+            <a:ext cx="10698480" cy="822960"/>
+          </a:xfrm>
+          <a:prstGeom prst="rect">
+            <a:avLst/>
+          </a:prstGeom>
+          <a:noFill/>
+          <a:ln/>
+        </p:spPr>
+        <p:txBody>
+          <a:bodyPr wrap="square" lIns="0" tIns="0" rIns="0" bIns="0" rtlCol="0" anchor="t"/>
+          <a:lstStyle/>
+          <a:p>
+            <a:pPr algn="l" indent="0" marL="0">
+              <a:buNone/>
+            </a:pPr>
+            <a:r>
+              <a:rPr lang="en-US" sz="3200" b="1" dirty="0">
+                <a:solidFill>
+                  <a:srgbClr val="FFFFFF"/>
+                </a:solidFill>
+              </a:rPr>
+              <a:t>Discussion</a:t>
+            </a:r>
+            <a:endParaRPr lang="en-US" sz="3200" dirty="0"/>
+          </a:p>
+        </p:txBody>
+      </p:sp>
+      <p:sp>
+        <p:nvSpPr>
+          <p:cNvPr id="3" name="Text 0"/>
+          <p:cNvSpPr/>
+          <p:nvPr>
+            <p:ph idx="101" type="body" hasCustomPrompt="1"/>
+          </p:nvPr>
+        </p:nvSpPr>
+        <p:spPr>
+          <a:xfrm>
+            <a:off x="731520" y="1554480"/>
+            <a:ext cx="10698480" cy="4754880"/>
+          </a:xfrm>
+          <a:prstGeom prst="rect">
+            <a:avLst/>
+          </a:prstGeom>
+          <a:noFill/>
+          <a:ln/>
+        </p:spPr>
+        <p:txBody>
+          <a:bodyPr wrap="square" rtlCol="0" anchor="t"/>
+          <a:lstStyle/>
+          <a:p>
+            <a:pPr algn="l" marL="342900" indent="-342900">
+              <a:spcAft>
+                <a:spcPts val="1000"/>
+              </a:spcAft>
+              <a:buSzPct val="100000"/>
+              <a:buChar char="•"/>
+            </a:pPr>
+            <a:r>
+              <a:rPr lang="en-US" sz="2400" dirty="0">
+                <a:solidFill>
+                  <a:srgbClr val="FFFFFF"/>
+                </a:solidFill>
+              </a:rPr>
+              <a:t>Which of the three domains affects your work most, and what decision in it could better data improve?</a:t>
+            </a:r>
+            <a:endParaRPr lang="en-US" sz="2400" dirty="0"/>
+          </a:p>
+          <a:p>
+            <a:pPr algn="l" marL="342900" indent="-342900">
+              <a:spcAft>
+                <a:spcPts val="1000"/>
+              </a:spcAft>
+              <a:buSzPct val="100000"/>
+              <a:buChar char="•"/>
+            </a:pPr>
+            <a:r>
+              <a:rPr lang="en-US" sz="2400" dirty="0">
+                <a:solidFill>
+                  <a:srgbClr val="FFFFFF"/>
+                </a:solidFill>
+              </a:rPr>
+              <a:t>Draw on your own experience and career, and apply today's seminar to that setting.</a:t>
+            </a:r>
+            <a:endParaRPr lang="en-US" sz="2400" dirty="0"/>
+          </a:p>
+        </p:txBody>
+      </p:sp>
+      <p:sp>
+        <p:nvSpPr>
+          <p:cNvPr id="25" name="Slide Number Placeholder 0"/>
+          <p:cNvSpPr>
+            <a:spLocks noGrp="1"/>
+          </p:cNvSpPr>
+          <p:nvPr>
+            <p:ph type="sldNum" sz="quarter" idx="4294967295"/>
+          </p:nvPr>
+        </p:nvSpPr>
+        <p:spPr>
+          <a:xfrm>
+            <a:off x="10972800" y="6400800"/>
+            <a:ext cx="548640" cy="274320"/>
+          </a:xfrm>
+          <a:prstGeom prst="rect">
+            <a:avLst/>
+          </a:prstGeom>
+          <a:extLst>
+            <a:ext uri="{C572A759-6A51-4108-AA02-DFA0A04FC94B}">
+              <ma14:wrappingTextBoxFlag xmlns:ma14="http://schemas.microsoft.com/office/mac/drawingml/2011/main" val="0"/>
+            </a:ext>
+          </a:extLst>
+        </p:spPr>
+        <p:txBody>
+          <a:bodyPr/>
+          <a:lstStyle>
+            <a:lvl1pPr>
+              <a:defRPr sz="1000">
+                <a:solidFill>
+                  <a:srgbClr val="BFBFBF"/>
+                </a:solidFill>
+              </a:defRPr>
+            </a:lvl1pPr>
+          </a:lstStyle>
+          <a:p>
+            <a:pPr algn="r"/>
+            <a:fld id="{F7021451-1387-4CA6-816F-3879F97B5CBC}" type="slidenum">
+              <a:rPr b="0" lang="en-US"/>
+              <a:t>7</a:t>
             </a:fld>
             <a:endParaRPr lang="en-US"/>
           </a:p>

</xml_diff>